<commit_message>
Tech Minute slides in $K
Co-Authored-By: Claude Opus 5.5 <noreply@anthropic.com>
Claude-Session: https://claude.ai/code/session_01Xa4nFVxuQGXmHARGph9WhS
</commit_message>
<xml_diff>
--- a/day2-deck/decks/Tech Minute - Review.pptx
+++ b/day2-deck/decks/Tech Minute - Review.pptx
@@ -1619,7 +1619,7 @@
                           <a:ea typeface="Inter" pitchFamily="34" charset="-122"/>
                           <a:cs typeface="Inter" pitchFamily="34" charset="-120"/>
                         </a:rPr>
-                        <a:t>$37,032</a:t>
+                        <a:t>$37K</a:t>
                       </a:r>
                       <a:endParaRPr lang="en-US" sz="2000" dirty="0">
                         <a:latin typeface="Inter" charset="0"/>
@@ -1663,7 +1663,7 @@
                           <a:ea typeface="Inter" pitchFamily="34" charset="-122"/>
                           <a:cs typeface="Inter" pitchFamily="34" charset="-120"/>
                         </a:rPr>
-                        <a:t>$444,380</a:t>
+                        <a:t>$444K</a:t>
                       </a:r>
                       <a:endParaRPr lang="en-US" sz="2000" dirty="0">
                         <a:latin typeface="Inter" charset="0"/>
@@ -1753,7 +1753,7 @@
                           <a:ea typeface="Inter" pitchFamily="34" charset="-122"/>
                           <a:cs typeface="Inter" pitchFamily="34" charset="-120"/>
                         </a:rPr>
-                        <a:t>$185,159</a:t>
+                        <a:t>$185K</a:t>
                       </a:r>
                       <a:endParaRPr lang="en-US" sz="2000" dirty="0">
                         <a:latin typeface="Inter" charset="0"/>
@@ -1797,7 +1797,7 @@
                           <a:ea typeface="Inter" pitchFamily="34" charset="-122"/>
                           <a:cs typeface="Inter" pitchFamily="34" charset="-120"/>
                         </a:rPr>
-                        <a:t>$2,221,902</a:t>
+                        <a:t>$2.22M</a:t>
                       </a:r>
                       <a:endParaRPr lang="en-US" sz="2000" dirty="0">
                         <a:latin typeface="Inter" charset="0"/>
@@ -1887,7 +1887,7 @@
                           <a:ea typeface="Inter" pitchFamily="34" charset="-122"/>
                           <a:cs typeface="Inter" pitchFamily="34" charset="-120"/>
                         </a:rPr>
-                        <a:t>$370,317</a:t>
+                        <a:t>$370K</a:t>
                       </a:r>
                       <a:endParaRPr lang="en-US" sz="2000" dirty="0">
                         <a:latin typeface="Inter" charset="0"/>
@@ -1931,7 +1931,7 @@
                           <a:ea typeface="Inter" pitchFamily="34" charset="-122"/>
                           <a:cs typeface="Inter" pitchFamily="34" charset="-120"/>
                         </a:rPr>
-                        <a:t>$4,443,804</a:t>
+                        <a:t>$4.44M</a:t>
                       </a:r>
                       <a:endParaRPr lang="en-US" sz="2000" dirty="0">
                         <a:latin typeface="Inter" charset="0"/>
@@ -2021,7 +2021,7 @@
                           <a:ea typeface="Inter" pitchFamily="34" charset="-122"/>
                           <a:cs typeface="Inter" pitchFamily="34" charset="-120"/>
                         </a:rPr>
-                        <a:t>$555,476</a:t>
+                        <a:t>$555K</a:t>
                       </a:r>
                       <a:endParaRPr lang="en-US" sz="2000" dirty="0">
                         <a:latin typeface="Inter" charset="0"/>
@@ -2065,7 +2065,7 @@
                           <a:ea typeface="Inter" pitchFamily="34" charset="-122"/>
                           <a:cs typeface="Inter" pitchFamily="34" charset="-120"/>
                         </a:rPr>
-                        <a:t>$6,665,706</a:t>
+                        <a:t>$6.67M</a:t>
                       </a:r>
                       <a:endParaRPr lang="en-US" sz="2000" dirty="0">
                         <a:latin typeface="Inter" charset="0"/>
@@ -2369,17 +2369,6 @@
             <a:pPr algn="r" indent="0" marL="0">
               <a:buNone/>
             </a:pPr>
-            <a:r>
-              <a:rPr lang="en-US" sz="1400" b="1" dirty="0">
-                <a:solidFill>
-                  <a:srgbClr val="595959"/>
-                </a:solidFill>
-                <a:latin typeface="Inter" pitchFamily="34" charset="0"/>
-                <a:ea typeface="Inter" pitchFamily="34" charset="-122"/>
-                <a:cs typeface="Inter" pitchFamily="34" charset="-120"/>
-              </a:rPr>
-              <a:t>A year</a:t>
-            </a:r>
             <a:endParaRPr lang="en-US" sz="1400" dirty="0"/>
           </a:p>
         </p:txBody>
@@ -2486,17 +2475,6 @@
             <a:pPr algn="r" indent="0" marL="0">
               <a:buNone/>
             </a:pPr>
-            <a:r>
-              <a:rPr lang="en-US" sz="1400" b="1" dirty="0">
-                <a:solidFill>
-                  <a:srgbClr val="595959"/>
-                </a:solidFill>
-                <a:latin typeface="Inter" pitchFamily="34" charset="0"/>
-                <a:ea typeface="Inter" pitchFamily="34" charset="-122"/>
-                <a:cs typeface="Inter" pitchFamily="34" charset="-120"/>
-              </a:rPr>
-              <a:t>A year</a:t>
-            </a:r>
             <a:endParaRPr lang="en-US" sz="1400" dirty="0"/>
           </a:p>
         </p:txBody>
@@ -2665,13 +2643,13 @@
             <a:r>
               <a:rPr lang="en-US" sz="1300" b="1" dirty="0">
                 <a:solidFill>
-                  <a:srgbClr val="0B2C4A"/>
-                </a:solidFill>
-                <a:latin typeface="Inter" pitchFamily="34" charset="0"/>
-                <a:ea typeface="Inter" pitchFamily="34" charset="-122"/>
-                <a:cs typeface="Inter" pitchFamily="34" charset="-120"/>
-              </a:rPr>
-              <a:t>$43,256</a:t>
+                  <a:srgbClr val="1A1A1A"/>
+                </a:solidFill>
+                <a:latin typeface="Inter" pitchFamily="34" charset="0"/>
+                <a:ea typeface="Inter" pitchFamily="34" charset="-122"/>
+                <a:cs typeface="Inter" pitchFamily="34" charset="-120"/>
+              </a:rPr>
+              <a:t>$43.3K</a:t>
             </a:r>
             <a:endParaRPr lang="en-US" sz="1300" dirty="0"/>
           </a:p>
@@ -2841,13 +2819,13 @@
             <a:r>
               <a:rPr lang="en-US" sz="1300" b="1" dirty="0">
                 <a:solidFill>
-                  <a:srgbClr val="0B2C4A"/>
-                </a:solidFill>
-                <a:latin typeface="Inter" pitchFamily="34" charset="0"/>
-                <a:ea typeface="Inter" pitchFamily="34" charset="-122"/>
-                <a:cs typeface="Inter" pitchFamily="34" charset="-120"/>
-              </a:rPr>
-              <a:t>$33,767</a:t>
+                  <a:srgbClr val="1A1A1A"/>
+                </a:solidFill>
+                <a:latin typeface="Inter" pitchFamily="34" charset="0"/>
+                <a:ea typeface="Inter" pitchFamily="34" charset="-122"/>
+                <a:cs typeface="Inter" pitchFamily="34" charset="-120"/>
+              </a:rPr>
+              <a:t>$33.8K</a:t>
             </a:r>
             <a:endParaRPr lang="en-US" sz="1300" dirty="0"/>
           </a:p>
@@ -3017,13 +2995,13 @@
             <a:r>
               <a:rPr lang="en-US" sz="1300" b="1" dirty="0">
                 <a:solidFill>
-                  <a:srgbClr val="0B2C4A"/>
-                </a:solidFill>
-                <a:latin typeface="Inter" pitchFamily="34" charset="0"/>
-                <a:ea typeface="Inter" pitchFamily="34" charset="-122"/>
-                <a:cs typeface="Inter" pitchFamily="34" charset="-120"/>
-              </a:rPr>
-              <a:t>$28,367</a:t>
+                  <a:srgbClr val="1A1A1A"/>
+                </a:solidFill>
+                <a:latin typeface="Inter" pitchFamily="34" charset="0"/>
+                <a:ea typeface="Inter" pitchFamily="34" charset="-122"/>
+                <a:cs typeface="Inter" pitchFamily="34" charset="-120"/>
+              </a:rPr>
+              <a:t>$28.4K</a:t>
             </a:r>
             <a:endParaRPr lang="en-US" sz="1300" dirty="0"/>
           </a:p>
@@ -3193,13 +3171,13 @@
             <a:r>
               <a:rPr lang="en-US" sz="1300" b="1" dirty="0">
                 <a:solidFill>
-                  <a:srgbClr val="0B2C4A"/>
-                </a:solidFill>
-                <a:latin typeface="Inter" pitchFamily="34" charset="0"/>
-                <a:ea typeface="Inter" pitchFamily="34" charset="-122"/>
-                <a:cs typeface="Inter" pitchFamily="34" charset="-120"/>
-              </a:rPr>
-              <a:t>$27,253</a:t>
+                  <a:srgbClr val="1A1A1A"/>
+                </a:solidFill>
+                <a:latin typeface="Inter" pitchFamily="34" charset="0"/>
+                <a:ea typeface="Inter" pitchFamily="34" charset="-122"/>
+                <a:cs typeface="Inter" pitchFamily="34" charset="-120"/>
+              </a:rPr>
+              <a:t>$27.3K</a:t>
             </a:r>
             <a:endParaRPr lang="en-US" sz="1300" dirty="0"/>
           </a:p>
@@ -3369,13 +3347,13 @@
             <a:r>
               <a:rPr lang="en-US" sz="1300" b="1" dirty="0">
                 <a:solidFill>
-                  <a:srgbClr val="0B2C4A"/>
-                </a:solidFill>
-                <a:latin typeface="Inter" pitchFamily="34" charset="0"/>
-                <a:ea typeface="Inter" pitchFamily="34" charset="-122"/>
-                <a:cs typeface="Inter" pitchFamily="34" charset="-120"/>
-              </a:rPr>
-              <a:t>$24,916</a:t>
+                  <a:srgbClr val="1A1A1A"/>
+                </a:solidFill>
+                <a:latin typeface="Inter" pitchFamily="34" charset="0"/>
+                <a:ea typeface="Inter" pitchFamily="34" charset="-122"/>
+                <a:cs typeface="Inter" pitchFamily="34" charset="-120"/>
+              </a:rPr>
+              <a:t>$24.9K</a:t>
             </a:r>
             <a:endParaRPr lang="en-US" sz="1300" dirty="0"/>
           </a:p>
@@ -3545,13 +3523,13 @@
             <a:r>
               <a:rPr lang="en-US" sz="1300" b="1" dirty="0">
                 <a:solidFill>
-                  <a:srgbClr val="0B2C4A"/>
-                </a:solidFill>
-                <a:latin typeface="Inter" pitchFamily="34" charset="0"/>
-                <a:ea typeface="Inter" pitchFamily="34" charset="-122"/>
-                <a:cs typeface="Inter" pitchFamily="34" charset="-120"/>
-              </a:rPr>
-              <a:t>$22,777</a:t>
+                  <a:srgbClr val="1A1A1A"/>
+                </a:solidFill>
+                <a:latin typeface="Inter" pitchFamily="34" charset="0"/>
+                <a:ea typeface="Inter" pitchFamily="34" charset="-122"/>
+                <a:cs typeface="Inter" pitchFamily="34" charset="-120"/>
+              </a:rPr>
+              <a:t>$22.8K</a:t>
             </a:r>
             <a:endParaRPr lang="en-US" sz="1300" dirty="0"/>
           </a:p>
@@ -3721,13 +3699,13 @@
             <a:r>
               <a:rPr lang="en-US" sz="1300" b="1" dirty="0">
                 <a:solidFill>
-                  <a:srgbClr val="0B2C4A"/>
-                </a:solidFill>
-                <a:latin typeface="Inter" pitchFamily="34" charset="0"/>
-                <a:ea typeface="Inter" pitchFamily="34" charset="-122"/>
-                <a:cs typeface="Inter" pitchFamily="34" charset="-120"/>
-              </a:rPr>
-              <a:t>$16,315</a:t>
+                  <a:srgbClr val="1A1A1A"/>
+                </a:solidFill>
+                <a:latin typeface="Inter" pitchFamily="34" charset="0"/>
+                <a:ea typeface="Inter" pitchFamily="34" charset="-122"/>
+                <a:cs typeface="Inter" pitchFamily="34" charset="-120"/>
+              </a:rPr>
+              <a:t>$16.3K</a:t>
             </a:r>
             <a:endParaRPr lang="en-US" sz="1300" dirty="0"/>
           </a:p>
@@ -3897,13 +3875,13 @@
             <a:r>
               <a:rPr lang="en-US" sz="1300" b="1" dirty="0">
                 <a:solidFill>
-                  <a:srgbClr val="0B2C4A"/>
-                </a:solidFill>
-                <a:latin typeface="Inter" pitchFamily="34" charset="0"/>
-                <a:ea typeface="Inter" pitchFamily="34" charset="-122"/>
-                <a:cs typeface="Inter" pitchFamily="34" charset="-120"/>
-              </a:rPr>
-              <a:t>$16,240</a:t>
+                  <a:srgbClr val="1A1A1A"/>
+                </a:solidFill>
+                <a:latin typeface="Inter" pitchFamily="34" charset="0"/>
+                <a:ea typeface="Inter" pitchFamily="34" charset="-122"/>
+                <a:cs typeface="Inter" pitchFamily="34" charset="-120"/>
+              </a:rPr>
+              <a:t>$16.2K</a:t>
             </a:r>
             <a:endParaRPr lang="en-US" sz="1300" dirty="0"/>
           </a:p>
@@ -4073,13 +4051,13 @@
             <a:r>
               <a:rPr lang="en-US" sz="1300" b="1" dirty="0">
                 <a:solidFill>
-                  <a:srgbClr val="0B2C4A"/>
-                </a:solidFill>
-                <a:latin typeface="Inter" pitchFamily="34" charset="0"/>
-                <a:ea typeface="Inter" pitchFamily="34" charset="-122"/>
-                <a:cs typeface="Inter" pitchFamily="34" charset="-120"/>
-              </a:rPr>
-              <a:t>$15,245</a:t>
+                  <a:srgbClr val="1A1A1A"/>
+                </a:solidFill>
+                <a:latin typeface="Inter" pitchFamily="34" charset="0"/>
+                <a:ea typeface="Inter" pitchFamily="34" charset="-122"/>
+                <a:cs typeface="Inter" pitchFamily="34" charset="-120"/>
+              </a:rPr>
+              <a:t>$15.2K</a:t>
             </a:r>
             <a:endParaRPr lang="en-US" sz="1300" dirty="0"/>
           </a:p>
@@ -4249,13 +4227,13 @@
             <a:r>
               <a:rPr lang="en-US" sz="1300" b="1" dirty="0">
                 <a:solidFill>
-                  <a:srgbClr val="0B2C4A"/>
-                </a:solidFill>
-                <a:latin typeface="Inter" pitchFamily="34" charset="0"/>
-                <a:ea typeface="Inter" pitchFamily="34" charset="-122"/>
-                <a:cs typeface="Inter" pitchFamily="34" charset="-120"/>
-              </a:rPr>
-              <a:t>$14,741</a:t>
+                  <a:srgbClr val="1A1A1A"/>
+                </a:solidFill>
+                <a:latin typeface="Inter" pitchFamily="34" charset="0"/>
+                <a:ea typeface="Inter" pitchFamily="34" charset="-122"/>
+                <a:cs typeface="Inter" pitchFamily="34" charset="-120"/>
+              </a:rPr>
+              <a:t>$14.7K</a:t>
             </a:r>
             <a:endParaRPr lang="en-US" sz="1300" dirty="0"/>
           </a:p>
@@ -4425,13 +4403,13 @@
             <a:r>
               <a:rPr lang="en-US" sz="1300" b="1" dirty="0">
                 <a:solidFill>
-                  <a:srgbClr val="0B2C4A"/>
-                </a:solidFill>
-                <a:latin typeface="Inter" pitchFamily="34" charset="0"/>
-                <a:ea typeface="Inter" pitchFamily="34" charset="-122"/>
-                <a:cs typeface="Inter" pitchFamily="34" charset="-120"/>
-              </a:rPr>
-              <a:t>$14,053</a:t>
+                  <a:srgbClr val="1A1A1A"/>
+                </a:solidFill>
+                <a:latin typeface="Inter" pitchFamily="34" charset="0"/>
+                <a:ea typeface="Inter" pitchFamily="34" charset="-122"/>
+                <a:cs typeface="Inter" pitchFamily="34" charset="-120"/>
+              </a:rPr>
+              <a:t>$14.1K</a:t>
             </a:r>
             <a:endParaRPr lang="en-US" sz="1300" dirty="0"/>
           </a:p>
@@ -4601,13 +4579,13 @@
             <a:r>
               <a:rPr lang="en-US" sz="1300" b="1" dirty="0">
                 <a:solidFill>
-                  <a:srgbClr val="0B2C4A"/>
-                </a:solidFill>
-                <a:latin typeface="Inter" pitchFamily="34" charset="0"/>
-                <a:ea typeface="Inter" pitchFamily="34" charset="-122"/>
-                <a:cs typeface="Inter" pitchFamily="34" charset="-120"/>
-              </a:rPr>
-              <a:t>$12,684</a:t>
+                  <a:srgbClr val="1A1A1A"/>
+                </a:solidFill>
+                <a:latin typeface="Inter" pitchFamily="34" charset="0"/>
+                <a:ea typeface="Inter" pitchFamily="34" charset="-122"/>
+                <a:cs typeface="Inter" pitchFamily="34" charset="-120"/>
+              </a:rPr>
+              <a:t>$12.7K</a:t>
             </a:r>
             <a:endParaRPr lang="en-US" sz="1300" dirty="0"/>
           </a:p>
@@ -4777,13 +4755,13 @@
             <a:r>
               <a:rPr lang="en-US" sz="1300" b="1" dirty="0">
                 <a:solidFill>
-                  <a:srgbClr val="0B2C4A"/>
-                </a:solidFill>
-                <a:latin typeface="Inter" pitchFamily="34" charset="0"/>
-                <a:ea typeface="Inter" pitchFamily="34" charset="-122"/>
-                <a:cs typeface="Inter" pitchFamily="34" charset="-120"/>
-              </a:rPr>
-              <a:t>$12,574</a:t>
+                  <a:srgbClr val="1A1A1A"/>
+                </a:solidFill>
+                <a:latin typeface="Inter" pitchFamily="34" charset="0"/>
+                <a:ea typeface="Inter" pitchFamily="34" charset="-122"/>
+                <a:cs typeface="Inter" pitchFamily="34" charset="-120"/>
+              </a:rPr>
+              <a:t>$12.6K</a:t>
             </a:r>
             <a:endParaRPr lang="en-US" sz="1300" dirty="0"/>
           </a:p>
@@ -4953,13 +4931,13 @@
             <a:r>
               <a:rPr lang="en-US" sz="1300" b="1" dirty="0">
                 <a:solidFill>
-                  <a:srgbClr val="0B2C4A"/>
-                </a:solidFill>
-                <a:latin typeface="Inter" pitchFamily="34" charset="0"/>
-                <a:ea typeface="Inter" pitchFamily="34" charset="-122"/>
-                <a:cs typeface="Inter" pitchFamily="34" charset="-120"/>
-              </a:rPr>
-              <a:t>$12,330</a:t>
+                  <a:srgbClr val="1A1A1A"/>
+                </a:solidFill>
+                <a:latin typeface="Inter" pitchFamily="34" charset="0"/>
+                <a:ea typeface="Inter" pitchFamily="34" charset="-122"/>
+                <a:cs typeface="Inter" pitchFamily="34" charset="-120"/>
+              </a:rPr>
+              <a:t>$12.3K</a:t>
             </a:r>
             <a:endParaRPr lang="en-US" sz="1300" dirty="0"/>
           </a:p>
@@ -5129,13 +5107,13 @@
             <a:r>
               <a:rPr lang="en-US" sz="1300" b="1" dirty="0">
                 <a:solidFill>
-                  <a:srgbClr val="0B2C4A"/>
-                </a:solidFill>
-                <a:latin typeface="Inter" pitchFamily="34" charset="0"/>
-                <a:ea typeface="Inter" pitchFamily="34" charset="-122"/>
-                <a:cs typeface="Inter" pitchFamily="34" charset="-120"/>
-              </a:rPr>
-              <a:t>$11,942</a:t>
+                  <a:srgbClr val="1A1A1A"/>
+                </a:solidFill>
+                <a:latin typeface="Inter" pitchFamily="34" charset="0"/>
+                <a:ea typeface="Inter" pitchFamily="34" charset="-122"/>
+                <a:cs typeface="Inter" pitchFamily="34" charset="-120"/>
+              </a:rPr>
+              <a:t>$11.9K</a:t>
             </a:r>
             <a:endParaRPr lang="en-US" sz="1300" dirty="0"/>
           </a:p>
@@ -5305,13 +5283,13 @@
             <a:r>
               <a:rPr lang="en-US" sz="1300" b="1" dirty="0">
                 <a:solidFill>
-                  <a:srgbClr val="0B2C4A"/>
-                </a:solidFill>
-                <a:latin typeface="Inter" pitchFamily="34" charset="0"/>
-                <a:ea typeface="Inter" pitchFamily="34" charset="-122"/>
-                <a:cs typeface="Inter" pitchFamily="34" charset="-120"/>
-              </a:rPr>
-              <a:t>$11,409</a:t>
+                  <a:srgbClr val="1A1A1A"/>
+                </a:solidFill>
+                <a:latin typeface="Inter" pitchFamily="34" charset="0"/>
+                <a:ea typeface="Inter" pitchFamily="34" charset="-122"/>
+                <a:cs typeface="Inter" pitchFamily="34" charset="-120"/>
+              </a:rPr>
+              <a:t>$11.4K</a:t>
             </a:r>
             <a:endParaRPr lang="en-US" sz="1300" dirty="0"/>
           </a:p>
@@ -5481,13 +5459,13 @@
             <a:r>
               <a:rPr lang="en-US" sz="1300" b="1" dirty="0">
                 <a:solidFill>
-                  <a:srgbClr val="0B2C4A"/>
-                </a:solidFill>
-                <a:latin typeface="Inter" pitchFamily="34" charset="0"/>
-                <a:ea typeface="Inter" pitchFamily="34" charset="-122"/>
-                <a:cs typeface="Inter" pitchFamily="34" charset="-120"/>
-              </a:rPr>
-              <a:t>$10,798</a:t>
+                  <a:srgbClr val="1A1A1A"/>
+                </a:solidFill>
+                <a:latin typeface="Inter" pitchFamily="34" charset="0"/>
+                <a:ea typeface="Inter" pitchFamily="34" charset="-122"/>
+                <a:cs typeface="Inter" pitchFamily="34" charset="-120"/>
+              </a:rPr>
+              <a:t>$10.8K</a:t>
             </a:r>
             <a:endParaRPr lang="en-US" sz="1300" dirty="0"/>
           </a:p>
@@ -5657,13 +5635,13 @@
             <a:r>
               <a:rPr lang="en-US" sz="1300" b="1" dirty="0">
                 <a:solidFill>
-                  <a:srgbClr val="0B2C4A"/>
-                </a:solidFill>
-                <a:latin typeface="Inter" pitchFamily="34" charset="0"/>
-                <a:ea typeface="Inter" pitchFamily="34" charset="-122"/>
-                <a:cs typeface="Inter" pitchFamily="34" charset="-120"/>
-              </a:rPr>
-              <a:t>$10,212</a:t>
+                  <a:srgbClr val="1A1A1A"/>
+                </a:solidFill>
+                <a:latin typeface="Inter" pitchFamily="34" charset="0"/>
+                <a:ea typeface="Inter" pitchFamily="34" charset="-122"/>
+                <a:cs typeface="Inter" pitchFamily="34" charset="-120"/>
+              </a:rPr>
+              <a:t>$10.2K</a:t>
             </a:r>
             <a:endParaRPr lang="en-US" sz="1300" dirty="0"/>
           </a:p>
@@ -5833,13 +5811,13 @@
             <a:r>
               <a:rPr lang="en-US" sz="1300" b="1" dirty="0">
                 <a:solidFill>
-                  <a:srgbClr val="0B2C4A"/>
-                </a:solidFill>
-                <a:latin typeface="Inter" pitchFamily="34" charset="0"/>
-                <a:ea typeface="Inter" pitchFamily="34" charset="-122"/>
-                <a:cs typeface="Inter" pitchFamily="34" charset="-120"/>
-              </a:rPr>
-              <a:t>$9,154</a:t>
+                  <a:srgbClr val="1A1A1A"/>
+                </a:solidFill>
+                <a:latin typeface="Inter" pitchFamily="34" charset="0"/>
+                <a:ea typeface="Inter" pitchFamily="34" charset="-122"/>
+                <a:cs typeface="Inter" pitchFamily="34" charset="-120"/>
+              </a:rPr>
+              <a:t>$9.2K</a:t>
             </a:r>
             <a:endParaRPr lang="en-US" sz="1300" dirty="0"/>
           </a:p>
@@ -6009,13 +5987,13 @@
             <a:r>
               <a:rPr lang="en-US" sz="1300" b="1" dirty="0">
                 <a:solidFill>
-                  <a:srgbClr val="0B2C4A"/>
-                </a:solidFill>
-                <a:latin typeface="Inter" pitchFamily="34" charset="0"/>
-                <a:ea typeface="Inter" pitchFamily="34" charset="-122"/>
-                <a:cs typeface="Inter" pitchFamily="34" charset="-120"/>
-              </a:rPr>
-              <a:t>$8,804</a:t>
+                  <a:srgbClr val="1A1A1A"/>
+                </a:solidFill>
+                <a:latin typeface="Inter" pitchFamily="34" charset="0"/>
+                <a:ea typeface="Inter" pitchFamily="34" charset="-122"/>
+                <a:cs typeface="Inter" pitchFamily="34" charset="-120"/>
+              </a:rPr>
+              <a:t>$8.8K</a:t>
             </a:r>
             <a:endParaRPr lang="en-US" sz="1300" dirty="0"/>
           </a:p>
@@ -6185,13 +6163,13 @@
             <a:r>
               <a:rPr lang="en-US" sz="1300" b="1" dirty="0">
                 <a:solidFill>
-                  <a:srgbClr val="0B2C4A"/>
-                </a:solidFill>
-                <a:latin typeface="Inter" pitchFamily="34" charset="0"/>
-                <a:ea typeface="Inter" pitchFamily="34" charset="-122"/>
-                <a:cs typeface="Inter" pitchFamily="34" charset="-120"/>
-              </a:rPr>
-              <a:t>$8,452</a:t>
+                  <a:srgbClr val="1A1A1A"/>
+                </a:solidFill>
+                <a:latin typeface="Inter" pitchFamily="34" charset="0"/>
+                <a:ea typeface="Inter" pitchFamily="34" charset="-122"/>
+                <a:cs typeface="Inter" pitchFamily="34" charset="-120"/>
+              </a:rPr>
+              <a:t>$8.5K</a:t>
             </a:r>
             <a:endParaRPr lang="en-US" sz="1300" dirty="0"/>
           </a:p>
@@ -6361,13 +6339,13 @@
             <a:r>
               <a:rPr lang="en-US" sz="1300" b="1" dirty="0">
                 <a:solidFill>
-                  <a:srgbClr val="0B2C4A"/>
-                </a:solidFill>
-                <a:latin typeface="Inter" pitchFamily="34" charset="0"/>
-                <a:ea typeface="Inter" pitchFamily="34" charset="-122"/>
-                <a:cs typeface="Inter" pitchFamily="34" charset="-120"/>
-              </a:rPr>
-              <a:t>$8,285</a:t>
+                  <a:srgbClr val="1A1A1A"/>
+                </a:solidFill>
+                <a:latin typeface="Inter" pitchFamily="34" charset="0"/>
+                <a:ea typeface="Inter" pitchFamily="34" charset="-122"/>
+                <a:cs typeface="Inter" pitchFamily="34" charset="-120"/>
+              </a:rPr>
+              <a:t>$8.3K</a:t>
             </a:r>
             <a:endParaRPr lang="en-US" sz="1300" dirty="0"/>
           </a:p>
@@ -6537,13 +6515,13 @@
             <a:r>
               <a:rPr lang="en-US" sz="1300" b="1" dirty="0">
                 <a:solidFill>
-                  <a:srgbClr val="0B2C4A"/>
-                </a:solidFill>
-                <a:latin typeface="Inter" pitchFamily="34" charset="0"/>
-                <a:ea typeface="Inter" pitchFamily="34" charset="-122"/>
-                <a:cs typeface="Inter" pitchFamily="34" charset="-120"/>
-              </a:rPr>
-              <a:t>$8,069</a:t>
+                  <a:srgbClr val="1A1A1A"/>
+                </a:solidFill>
+                <a:latin typeface="Inter" pitchFamily="34" charset="0"/>
+                <a:ea typeface="Inter" pitchFamily="34" charset="-122"/>
+                <a:cs typeface="Inter" pitchFamily="34" charset="-120"/>
+              </a:rPr>
+              <a:t>$8.1K</a:t>
             </a:r>
             <a:endParaRPr lang="en-US" sz="1300" dirty="0"/>
           </a:p>
@@ -6713,13 +6691,13 @@
             <a:r>
               <a:rPr lang="en-US" sz="1300" b="1" dirty="0">
                 <a:solidFill>
-                  <a:srgbClr val="0B2C4A"/>
-                </a:solidFill>
-                <a:latin typeface="Inter" pitchFamily="34" charset="0"/>
-                <a:ea typeface="Inter" pitchFamily="34" charset="-122"/>
-                <a:cs typeface="Inter" pitchFamily="34" charset="-120"/>
-              </a:rPr>
-              <a:t>$7,547</a:t>
+                  <a:srgbClr val="1A1A1A"/>
+                </a:solidFill>
+                <a:latin typeface="Inter" pitchFamily="34" charset="0"/>
+                <a:ea typeface="Inter" pitchFamily="34" charset="-122"/>
+                <a:cs typeface="Inter" pitchFamily="34" charset="-120"/>
+              </a:rPr>
+              <a:t>$7.5K</a:t>
             </a:r>
             <a:endParaRPr lang="en-US" sz="1300" dirty="0"/>
           </a:p>
@@ -6889,13 +6867,13 @@
             <a:r>
               <a:rPr lang="en-US" sz="1300" b="1" dirty="0">
                 <a:solidFill>
-                  <a:srgbClr val="0B2C4A"/>
-                </a:solidFill>
-                <a:latin typeface="Inter" pitchFamily="34" charset="0"/>
-                <a:ea typeface="Inter" pitchFamily="34" charset="-122"/>
-                <a:cs typeface="Inter" pitchFamily="34" charset="-120"/>
-              </a:rPr>
-              <a:t>$7,394</a:t>
+                  <a:srgbClr val="1A1A1A"/>
+                </a:solidFill>
+                <a:latin typeface="Inter" pitchFamily="34" charset="0"/>
+                <a:ea typeface="Inter" pitchFamily="34" charset="-122"/>
+                <a:cs typeface="Inter" pitchFamily="34" charset="-120"/>
+              </a:rPr>
+              <a:t>$7.4K</a:t>
             </a:r>
             <a:endParaRPr lang="en-US" sz="1300" dirty="0"/>
           </a:p>
@@ -7065,13 +7043,13 @@
             <a:r>
               <a:rPr lang="en-US" sz="1300" b="1" dirty="0">
                 <a:solidFill>
-                  <a:srgbClr val="0B2C4A"/>
-                </a:solidFill>
-                <a:latin typeface="Inter" pitchFamily="34" charset="0"/>
-                <a:ea typeface="Inter" pitchFamily="34" charset="-122"/>
-                <a:cs typeface="Inter" pitchFamily="34" charset="-120"/>
-              </a:rPr>
-              <a:t>$7,249</a:t>
+                  <a:srgbClr val="1A1A1A"/>
+                </a:solidFill>
+                <a:latin typeface="Inter" pitchFamily="34" charset="0"/>
+                <a:ea typeface="Inter" pitchFamily="34" charset="-122"/>
+                <a:cs typeface="Inter" pitchFamily="34" charset="-120"/>
+              </a:rPr>
+              <a:t>$7.2K</a:t>
             </a:r>
             <a:endParaRPr lang="en-US" sz="1300" dirty="0"/>
           </a:p>
@@ -7241,13 +7219,13 @@
             <a:r>
               <a:rPr lang="en-US" sz="1300" b="1" dirty="0">
                 <a:solidFill>
-                  <a:srgbClr val="0B2C4A"/>
-                </a:solidFill>
-                <a:latin typeface="Inter" pitchFamily="34" charset="0"/>
-                <a:ea typeface="Inter" pitchFamily="34" charset="-122"/>
-                <a:cs typeface="Inter" pitchFamily="34" charset="-120"/>
-              </a:rPr>
-              <a:t>$7,225</a:t>
+                  <a:srgbClr val="1A1A1A"/>
+                </a:solidFill>
+                <a:latin typeface="Inter" pitchFamily="34" charset="0"/>
+                <a:ea typeface="Inter" pitchFamily="34" charset="-122"/>
+                <a:cs typeface="Inter" pitchFamily="34" charset="-120"/>
+              </a:rPr>
+              <a:t>$7.2K</a:t>
             </a:r>
             <a:endParaRPr lang="en-US" sz="1300" dirty="0"/>
           </a:p>
@@ -7417,13 +7395,13 @@
             <a:r>
               <a:rPr lang="en-US" sz="1300" b="1" dirty="0">
                 <a:solidFill>
-                  <a:srgbClr val="0B2C4A"/>
-                </a:solidFill>
-                <a:latin typeface="Inter" pitchFamily="34" charset="0"/>
-                <a:ea typeface="Inter" pitchFamily="34" charset="-122"/>
-                <a:cs typeface="Inter" pitchFamily="34" charset="-120"/>
-              </a:rPr>
-              <a:t>$7,141</a:t>
+                  <a:srgbClr val="1A1A1A"/>
+                </a:solidFill>
+                <a:latin typeface="Inter" pitchFamily="34" charset="0"/>
+                <a:ea typeface="Inter" pitchFamily="34" charset="-122"/>
+                <a:cs typeface="Inter" pitchFamily="34" charset="-120"/>
+              </a:rPr>
+              <a:t>$7.1K</a:t>
             </a:r>
             <a:endParaRPr lang="en-US" sz="1300" dirty="0"/>
           </a:p>
@@ -7593,13 +7571,13 @@
             <a:r>
               <a:rPr lang="en-US" sz="1300" b="1" dirty="0">
                 <a:solidFill>
-                  <a:srgbClr val="0B2C4A"/>
-                </a:solidFill>
-                <a:latin typeface="Inter" pitchFamily="34" charset="0"/>
-                <a:ea typeface="Inter" pitchFamily="34" charset="-122"/>
-                <a:cs typeface="Inter" pitchFamily="34" charset="-120"/>
-              </a:rPr>
-              <a:t>$6,583</a:t>
+                  <a:srgbClr val="1A1A1A"/>
+                </a:solidFill>
+                <a:latin typeface="Inter" pitchFamily="34" charset="0"/>
+                <a:ea typeface="Inter" pitchFamily="34" charset="-122"/>
+                <a:cs typeface="Inter" pitchFamily="34" charset="-120"/>
+              </a:rPr>
+              <a:t>$6.6K</a:t>
             </a:r>
             <a:endParaRPr lang="en-US" sz="1300" dirty="0"/>
           </a:p>
@@ -7769,13 +7747,13 @@
             <a:r>
               <a:rPr lang="en-US" sz="1300" b="1" dirty="0">
                 <a:solidFill>
-                  <a:srgbClr val="0B2C4A"/>
-                </a:solidFill>
-                <a:latin typeface="Inter" pitchFamily="34" charset="0"/>
-                <a:ea typeface="Inter" pitchFamily="34" charset="-122"/>
-                <a:cs typeface="Inter" pitchFamily="34" charset="-120"/>
-              </a:rPr>
-              <a:t>$6,512</a:t>
+                  <a:srgbClr val="1A1A1A"/>
+                </a:solidFill>
+                <a:latin typeface="Inter" pitchFamily="34" charset="0"/>
+                <a:ea typeface="Inter" pitchFamily="34" charset="-122"/>
+                <a:cs typeface="Inter" pitchFamily="34" charset="-120"/>
+              </a:rPr>
+              <a:t>$6.5K</a:t>
             </a:r>
             <a:endParaRPr lang="en-US" sz="1300" dirty="0"/>
           </a:p>
@@ -7945,13 +7923,13 @@
             <a:r>
               <a:rPr lang="en-US" sz="1300" b="1" dirty="0">
                 <a:solidFill>
-                  <a:srgbClr val="0B2C4A"/>
-                </a:solidFill>
-                <a:latin typeface="Inter" pitchFamily="34" charset="0"/>
-                <a:ea typeface="Inter" pitchFamily="34" charset="-122"/>
-                <a:cs typeface="Inter" pitchFamily="34" charset="-120"/>
-              </a:rPr>
-              <a:t>$5,294</a:t>
+                  <a:srgbClr val="1A1A1A"/>
+                </a:solidFill>
+                <a:latin typeface="Inter" pitchFamily="34" charset="0"/>
+                <a:ea typeface="Inter" pitchFamily="34" charset="-122"/>
+                <a:cs typeface="Inter" pitchFamily="34" charset="-120"/>
+              </a:rPr>
+              <a:t>$5.3K</a:t>
             </a:r>
             <a:endParaRPr lang="en-US" sz="1300" dirty="0"/>
           </a:p>
@@ -8121,13 +8099,13 @@
             <a:r>
               <a:rPr lang="en-US" sz="1300" b="1" dirty="0">
                 <a:solidFill>
-                  <a:srgbClr val="0B2C4A"/>
-                </a:solidFill>
-                <a:latin typeface="Inter" pitchFamily="34" charset="0"/>
-                <a:ea typeface="Inter" pitchFamily="34" charset="-122"/>
-                <a:cs typeface="Inter" pitchFamily="34" charset="-120"/>
-              </a:rPr>
-              <a:t>$4,334</a:t>
+                  <a:srgbClr val="1A1A1A"/>
+                </a:solidFill>
+                <a:latin typeface="Inter" pitchFamily="34" charset="0"/>
+                <a:ea typeface="Inter" pitchFamily="34" charset="-122"/>
+                <a:cs typeface="Inter" pitchFamily="34" charset="-120"/>
+              </a:rPr>
+              <a:t>$4.3K</a:t>
             </a:r>
             <a:endParaRPr lang="en-US" sz="1300" dirty="0"/>
           </a:p>
@@ -8297,13 +8275,13 @@
             <a:r>
               <a:rPr lang="en-US" sz="1300" b="1" dirty="0">
                 <a:solidFill>
-                  <a:srgbClr val="0B2C4A"/>
-                </a:solidFill>
-                <a:latin typeface="Inter" pitchFamily="34" charset="0"/>
-                <a:ea typeface="Inter" pitchFamily="34" charset="-122"/>
-                <a:cs typeface="Inter" pitchFamily="34" charset="-120"/>
-              </a:rPr>
-              <a:t>$3,458</a:t>
+                  <a:srgbClr val="1A1A1A"/>
+                </a:solidFill>
+                <a:latin typeface="Inter" pitchFamily="34" charset="0"/>
+                <a:ea typeface="Inter" pitchFamily="34" charset="-122"/>
+                <a:cs typeface="Inter" pitchFamily="34" charset="-120"/>
+              </a:rPr>
+              <a:t>$3.5K</a:t>
             </a:r>
             <a:endParaRPr lang="en-US" sz="1300" dirty="0"/>
           </a:p>

</xml_diff>